<commit_message>
Remove egg emoji and update footer to 岩瀬スポーツ公園管理事務所
https://claude.ai/code/session_01AkXARj4Ho43LrJg3TDyA5V
</commit_message>
<xml_diff>
--- a/カブトムシ幼虫配布チラシ.pptx
+++ b/カブトムシ幼虫配布チラシ.pptx
@@ -3274,8 +3274,7 @@
                 </a:solidFill>
                 <a:latin typeface="BIZ UDPGothic"/>
               </a:rPr>
-              <a:t>🐛
-🥚🌱</a:t>
+              <a:t>🐛</a:t>
             </a:r>
           </a:p>
         </p:txBody>
@@ -3438,8 +3437,8 @@
         </p:nvSpPr>
         <p:spPr>
           <a:xfrm>
-            <a:off x="360000" y="6192000"/>
-            <a:ext cx="9972000" cy="432000"/>
+            <a:off x="360000" y="6300000"/>
+            <a:ext cx="9972000" cy="1080000"/>
           </a:xfrm>
           <a:prstGeom prst="rect">
             <a:avLst/>
@@ -3454,56 +3453,20 @@
           <a:p>
             <a:pPr algn="ctr"/>
             <a:r>
-              <a:rPr sz="1600" b="1">
-                <a:solidFill>
-                  <a:srgbClr val="FFFFB4"/>
-                </a:solidFill>
-                <a:latin typeface="BIZ UDPGothic"/>
-              </a:rPr>
-              <a:t>【 お問い合わせ・お持ち帰り場所 】</a:t>
-            </a:r>
-          </a:p>
-        </p:txBody>
-      </p:sp>
-      <p:sp>
-        <p:nvSpPr>
-          <p:cNvPr id="10" name="TextBox 9"/>
-          <p:cNvSpPr txBox="1"/>
-          <p:nvPr/>
-        </p:nvSpPr>
-        <p:spPr>
-          <a:xfrm>
-            <a:off x="360000" y="6660000"/>
-            <a:ext cx="9972000" cy="792000"/>
-          </a:xfrm>
-          <a:prstGeom prst="rect">
-            <a:avLst/>
-          </a:prstGeom>
-          <a:noFill/>
-        </p:spPr>
-        <p:txBody>
-          <a:bodyPr wrap="square">
-            <a:spAutoFit/>
-          </a:bodyPr>
-          <a:lstStyle/>
-          <a:p>
-            <a:pPr algn="ctr"/>
-            <a:r>
-              <a:rPr sz="1500" b="0">
+              <a:rPr sz="2600" b="1">
                 <a:solidFill>
                   <a:srgbClr val="FFFFFF"/>
                 </a:solidFill>
                 <a:latin typeface="BIZ UDPGothic"/>
               </a:rPr>
-              <a:t>📍 場所：玄関前に置いてあります　　📞 連絡先：kq4ymgr@gmail.com
-🗓 期間：数がなくなり次第終了　　　🕐 お持ち帰り：いつでもどうぞ</a:t>
-            </a:r>
-          </a:p>
-        </p:txBody>
-      </p:sp>
-      <p:sp>
-        <p:nvSpPr>
-          <p:cNvPr id="11" name="Rectangle 10"/>
+              <a:t>岩瀬スポーツ公園管理事務所</a:t>
+            </a:r>
+          </a:p>
+        </p:txBody>
+      </p:sp>
+      <p:sp>
+        <p:nvSpPr>
+          <p:cNvPr id="10" name="Rectangle 9"/>
           <p:cNvSpPr/>
           <p:nvPr/>
         </p:nvSpPr>

</xml_diff>

<commit_message>
Fix overlapping layout: separate catch copy, emoji, and description
https://claude.ai/code/session_01AkXARj4Ho43LrJg3TDyA5V
</commit_message>
<xml_diff>
--- a/カブトムシ幼虫配布チラシ.pptx
+++ b/カブトムシ幼虫配布チラシ.pptx
@@ -3217,8 +3217,8 @@
         </p:nvSpPr>
         <p:spPr>
           <a:xfrm>
-            <a:off x="360000" y="1440000"/>
-            <a:ext cx="9972000" cy="1260000"/>
+            <a:off x="360000" y="1368000"/>
+            <a:ext cx="9972000" cy="900000"/>
           </a:xfrm>
           <a:prstGeom prst="rect">
             <a:avLst/>
@@ -3252,8 +3252,8 @@
         </p:nvSpPr>
         <p:spPr>
           <a:xfrm>
-            <a:off x="360000" y="2592000"/>
-            <a:ext cx="3600000" cy="2160000"/>
+            <a:off x="540000" y="2376000"/>
+            <a:ext cx="3240000" cy="3060000"/>
           </a:xfrm>
           <a:prstGeom prst="rect">
             <a:avLst/>
@@ -3268,7 +3268,7 @@
           <a:p>
             <a:pPr algn="ctr"/>
             <a:r>
-              <a:rPr sz="8000" b="0">
+              <a:rPr sz="10000" b="0">
                 <a:solidFill>
                   <a:srgbClr val="000000"/>
                 </a:solidFill>
@@ -3287,8 +3287,8 @@
         </p:nvSpPr>
         <p:spPr>
           <a:xfrm>
-            <a:off x="4320000" y="1440000"/>
-            <a:ext cx="5940000" cy="3600000"/>
+            <a:off x="4140000" y="2376000"/>
+            <a:ext cx="6120000" cy="3240000"/>
           </a:xfrm>
           <a:prstGeom prst="rect">
             <a:avLst/>
@@ -3394,8 +3394,8 @@
         </p:nvSpPr>
         <p:spPr>
           <a:xfrm>
-            <a:off x="0" y="6120000"/>
-            <a:ext cx="10692000" cy="1440000"/>
+            <a:off x="0" y="5940000"/>
+            <a:ext cx="10692000" cy="1620000"/>
           </a:xfrm>
           <a:prstGeom prst="rect">
             <a:avLst/>
@@ -3437,7 +3437,7 @@
         </p:nvSpPr>
         <p:spPr>
           <a:xfrm>
-            <a:off x="360000" y="6300000"/>
+            <a:off x="360000" y="6192000"/>
             <a:ext cx="9972000" cy="1080000"/>
           </a:xfrm>
           <a:prstGeom prst="rect">
@@ -3472,8 +3472,8 @@
         </p:nvSpPr>
         <p:spPr>
           <a:xfrm>
-            <a:off x="144000" y="1332000"/>
-            <a:ext cx="10404000" cy="4644000"/>
+            <a:off x="144000" y="1260000"/>
+            <a:ext cx="10404000" cy="4536000"/>
           </a:xfrm>
           <a:prstGeom prst="rect">
             <a:avLst/>

</xml_diff>

<commit_message>
Update illustrations to show beetle and larva emojis side by side
https://claude.ai/code/session_01AkXARj4Ho43LrJg3TDyA5V
</commit_message>
<xml_diff>
--- a/カブトムシ幼虫配布チラシ.pptx
+++ b/カブトムシ幼虫配布チラシ.pptx
@@ -3252,8 +3252,8 @@
         </p:nvSpPr>
         <p:spPr>
           <a:xfrm>
-            <a:off x="540000" y="2376000"/>
-            <a:ext cx="3240000" cy="3060000"/>
+            <a:off x="360000" y="2376000"/>
+            <a:ext cx="3420000" cy="1440000"/>
           </a:xfrm>
           <a:prstGeom prst="rect">
             <a:avLst/>
@@ -3268,7 +3268,42 @@
           <a:p>
             <a:pPr algn="ctr"/>
             <a:r>
-              <a:rPr sz="10000" b="0">
+              <a:rPr sz="9000" b="0">
+                <a:solidFill>
+                  <a:srgbClr val="000000"/>
+                </a:solidFill>
+                <a:latin typeface="BIZ UDPGothic"/>
+              </a:rPr>
+              <a:t>🪲</a:t>
+            </a:r>
+          </a:p>
+        </p:txBody>
+      </p:sp>
+      <p:sp>
+        <p:nvSpPr>
+          <p:cNvPr id="7" name="TextBox 6"/>
+          <p:cNvSpPr txBox="1"/>
+          <p:nvPr/>
+        </p:nvSpPr>
+        <p:spPr>
+          <a:xfrm>
+            <a:off x="360000" y="3888000"/>
+            <a:ext cx="3420000" cy="1440000"/>
+          </a:xfrm>
+          <a:prstGeom prst="rect">
+            <a:avLst/>
+          </a:prstGeom>
+          <a:noFill/>
+        </p:spPr>
+        <p:txBody>
+          <a:bodyPr wrap="square">
+            <a:spAutoFit/>
+          </a:bodyPr>
+          <a:lstStyle/>
+          <a:p>
+            <a:pPr algn="ctr"/>
+            <a:r>
+              <a:rPr sz="9000" b="0">
                 <a:solidFill>
                   <a:srgbClr val="000000"/>
                 </a:solidFill>
@@ -3281,7 +3316,7 @@
       </p:sp>
       <p:sp>
         <p:nvSpPr>
-          <p:cNvPr id="7" name="TextBox 6"/>
+          <p:cNvPr id="8" name="TextBox 7"/>
           <p:cNvSpPr txBox="1"/>
           <p:nvPr/>
         </p:nvSpPr>
@@ -3388,7 +3423,7 @@
       </p:sp>
       <p:sp>
         <p:nvSpPr>
-          <p:cNvPr id="8" name="Rectangle 7"/>
+          <p:cNvPr id="9" name="Rectangle 8"/>
           <p:cNvSpPr/>
           <p:nvPr/>
         </p:nvSpPr>
@@ -3431,7 +3466,7 @@
       </p:sp>
       <p:sp>
         <p:nvSpPr>
-          <p:cNvPr id="9" name="TextBox 8"/>
+          <p:cNvPr id="10" name="TextBox 9"/>
           <p:cNvSpPr txBox="1"/>
           <p:nvPr/>
         </p:nvSpPr>
@@ -3466,7 +3501,7 @@
       </p:sp>
       <p:sp>
         <p:nvSpPr>
-          <p:cNvPr id="10" name="Rectangle 9"/>
+          <p:cNvPr id="11" name="Rectangle 10"/>
           <p:cNvSpPr/>
           <p:nvPr/>
         </p:nvSpPr>

</xml_diff>